<commit_message>
docs: final pack for t11 (selected), Kohei Kudo, Week 2 rank 2; video guidance from the competition page (D84)
Co-Authored-By: Claude Sonnet 5.5 <noreply@anthropic.com>
Claude-Session: https://claude.ai/code/session_015FJt2Qsv88cxtF8e7yXTQp
</commit_message>
<xml_diff>
--- a/docs/final/video_slides.pptx
+++ b/docs/final/video_slides.pptx
@@ -507,7 +507,7 @@
           <a:lstStyle/>
           <a:p>
             <a:r>
-              <a:t>Result. Week 1: private rank 3 of 54, D2 0.13864. Week 2: the same engine, adapted to a market with two years of data. [add private result]</a:t>
+              <a:t>Result. Week 1: private rank 3 of 54, D2 0.13864. Week 2: the same engine, adapted to a market with two years of data; public 0.16458 for the final ensemble. Private: Rank 2.</a:t>
             </a:r>
           </a:p>
         </p:txBody>
@@ -3977,7 +3977,7 @@
               </a:defRPr>
             </a:pPr>
             <a:r>
-              <a:t>Team: [TEAM NAME] ([TEAM MEMBERS' NAMES])</a:t>
+              <a:t>Team: Kohei Kudo (Kohei Kudo (sole member))</a:t>
             </a:r>
           </a:p>
         </p:txBody>
@@ -4177,7 +4177,7 @@
               </a:defRPr>
             </a:pPr>
             <a:r>
-              <a:t>0.16462</a:t>
+              <a:t>0.16458</a:t>
             </a:r>
           </a:p>
         </p:txBody>
@@ -4296,7 +4296,7 @@
               </a:defRPr>
             </a:pPr>
             <a:r>
-              <a:t>[add private result]</a:t>
+              <a:t>Rank 2</a:t>
             </a:r>
           </a:p>
         </p:txBody>
@@ -4334,7 +4334,7 @@
               </a:defRPr>
             </a:pPr>
             <a:r>
-              <a:t>Week 2 private result</a:t>
+              <a:t>Week 2 private leaderboard</a:t>
             </a:r>
           </a:p>
         </p:txBody>
@@ -5662,7 +5662,7 @@
               </a:defRPr>
             </a:pPr>
             <a:r>
-              <a:t>3 tree models, 6 nets, 4 Tweedie GBMs, equal weights in groups</a:t>
+              <a:t>5 tree models, 7 nets, 4 Tweedie GBMs, equal weights in groups</a:t>
             </a:r>
           </a:p>
         </p:txBody>
@@ -6028,7 +6028,7 @@
               </a:defRPr>
             </a:pPr>
             <a:r>
-              <a:t>No emerging-only model: it scores 0.1110 against 0.1408 for the transfer.</a:t>
+              <a:t>No emerging-only model: it scores 0.1110 against 0.1405 for the transfer.</a:t>
             </a:r>
           </a:p>
           <a:p>
@@ -6583,7 +6583,7 @@
                         <a:defRPr sz="1400" b="0"/>
                       </a:pPr>
                       <a:r>
-                        <a:t>0.1408</a:t>
+                        <a:t>0.1405</a:t>
                       </a:r>
                     </a:p>
                   </a:txBody>
@@ -6598,7 +6598,7 @@
                         <a:defRPr sz="1400" b="0"/>
                       </a:pPr>
                       <a:r>
-                        <a:t>0.1272</a:t>
+                        <a:t>0.1268</a:t>
                       </a:r>
                     </a:p>
                   </a:txBody>

</xml_diff>